<commit_message>
Polish deck copy, limits notes, and Demo 3 screenshot.
Clarify Demo 1 session-cache bullet, document unsupported cursor query types on the limits slide, use soql> for Stable ORDER BY, and refresh the adaptive async demo capture.
</commit_message>
<xml_diff>
--- a/docs/presentation/lc26-apex-cursors.pptx
+++ b/docs/presentation/lc26-apex-cursors.pptx
@@ -16159,7 +16159,7 @@
                   <a:srgbClr val="6A9955"/>
                 </a:solidFill>
               </a:rPr>
-              <a:t>apex&gt;</a:t>
+              <a:t>soql&gt;</a:t>
             </a:r>
             <a:endParaRPr/>
           </a:p>
@@ -17898,7 +17898,7 @@
         </p:nvSpPr>
         <p:spPr>
           <a:xfrm>
-            <a:off x="338325" y="1446000"/>
+            <a:off x="338325" y="1346000"/>
             <a:ext cx="11484900" cy="3285000"/>
           </a:xfrm>
           <a:prstGeom prst="rect">
@@ -17936,7 +17936,7 @@
         </p:nvSpPr>
         <p:spPr>
           <a:xfrm>
-            <a:off x="338325" y="1446000"/>
+            <a:off x="338325" y="1346000"/>
             <a:ext cx="5972148" cy="420000"/>
           </a:xfrm>
           <a:prstGeom prst="rect">
@@ -17965,7 +17965,7 @@
         </p:nvSpPr>
         <p:spPr>
           <a:xfrm>
-            <a:off x="338325" y="1446000"/>
+            <a:off x="338325" y="1346000"/>
             <a:ext cx="5972148" cy="420000"/>
           </a:xfrm>
           <a:prstGeom prst="rect">
@@ -18014,7 +18014,7 @@
         </p:nvSpPr>
         <p:spPr>
           <a:xfrm>
-            <a:off x="6310473" y="1446000"/>
+            <a:off x="6310473" y="1346000"/>
             <a:ext cx="2756376" cy="420000"/>
           </a:xfrm>
           <a:prstGeom prst="rect">
@@ -18043,7 +18043,7 @@
         </p:nvSpPr>
         <p:spPr>
           <a:xfrm>
-            <a:off x="6310473" y="1446000"/>
+            <a:off x="6310473" y="1346000"/>
             <a:ext cx="2756376" cy="420000"/>
           </a:xfrm>
           <a:prstGeom prst="rect">
@@ -18092,7 +18092,7 @@
         </p:nvSpPr>
         <p:spPr>
           <a:xfrm>
-            <a:off x="9066849" y="1446000"/>
+            <a:off x="9066849" y="1346000"/>
             <a:ext cx="2756376" cy="420000"/>
           </a:xfrm>
           <a:prstGeom prst="rect">
@@ -18121,7 +18121,7 @@
         </p:nvSpPr>
         <p:spPr>
           <a:xfrm>
-            <a:off x="9066849" y="1446000"/>
+            <a:off x="9066849" y="1346000"/>
             <a:ext cx="2756376" cy="420000"/>
           </a:xfrm>
           <a:prstGeom prst="rect">
@@ -18170,7 +18170,7 @@
         </p:nvSpPr>
         <p:spPr>
           <a:xfrm>
-            <a:off x="338325" y="1866000"/>
+            <a:off x="338325" y="1766000"/>
             <a:ext cx="11484900" cy="285000"/>
           </a:xfrm>
           <a:prstGeom prst="rect">
@@ -18201,7 +18201,7 @@
         </p:nvSpPr>
         <p:spPr>
           <a:xfrm>
-            <a:off x="338325" y="1866000"/>
+            <a:off x="338325" y="1766000"/>
             <a:ext cx="11484900" cy="285000"/>
           </a:xfrm>
           <a:prstGeom prst="rect">
@@ -18250,7 +18250,7 @@
         </p:nvSpPr>
         <p:spPr>
           <a:xfrm>
-            <a:off x="338325" y="2151000"/>
+            <a:off x="338325" y="2051000"/>
             <a:ext cx="5972148" cy="335000"/>
           </a:xfrm>
           <a:prstGeom prst="rect">
@@ -18281,7 +18281,7 @@
         </p:nvSpPr>
         <p:spPr>
           <a:xfrm>
-            <a:off x="338325" y="2151000"/>
+            <a:off x="338325" y="2051000"/>
             <a:ext cx="5972148" cy="335000"/>
           </a:xfrm>
           <a:prstGeom prst="rect">
@@ -18330,7 +18330,7 @@
         </p:nvSpPr>
         <p:spPr>
           <a:xfrm>
-            <a:off x="6310473" y="2151000"/>
+            <a:off x="6310473" y="2051000"/>
             <a:ext cx="2756376" cy="335000"/>
           </a:xfrm>
           <a:prstGeom prst="rect">
@@ -18361,7 +18361,7 @@
         </p:nvSpPr>
         <p:spPr>
           <a:xfrm>
-            <a:off x="6310473" y="2151000"/>
+            <a:off x="6310473" y="2051000"/>
             <a:ext cx="2756376" cy="335000"/>
           </a:xfrm>
           <a:prstGeom prst="rect">
@@ -18410,7 +18410,7 @@
         </p:nvSpPr>
         <p:spPr>
           <a:xfrm>
-            <a:off x="9066849" y="2151000"/>
+            <a:off x="9066849" y="2051000"/>
             <a:ext cx="2756376" cy="335000"/>
           </a:xfrm>
           <a:prstGeom prst="rect">
@@ -18441,7 +18441,7 @@
         </p:nvSpPr>
         <p:spPr>
           <a:xfrm>
-            <a:off x="9066849" y="2151000"/>
+            <a:off x="9066849" y="2051000"/>
             <a:ext cx="2756376" cy="335000"/>
           </a:xfrm>
           <a:prstGeom prst="rect">
@@ -18490,7 +18490,7 @@
         </p:nvSpPr>
         <p:spPr>
           <a:xfrm>
-            <a:off x="338325" y="2486000"/>
+            <a:off x="338325" y="2386000"/>
             <a:ext cx="5972148" cy="335000"/>
           </a:xfrm>
           <a:prstGeom prst="rect">
@@ -18521,7 +18521,7 @@
         </p:nvSpPr>
         <p:spPr>
           <a:xfrm>
-            <a:off x="338325" y="2486000"/>
+            <a:off x="338325" y="2386000"/>
             <a:ext cx="5972148" cy="335000"/>
           </a:xfrm>
           <a:prstGeom prst="rect">
@@ -18570,7 +18570,7 @@
         </p:nvSpPr>
         <p:spPr>
           <a:xfrm>
-            <a:off x="6310473" y="2486000"/>
+            <a:off x="6310473" y="2386000"/>
             <a:ext cx="2756376" cy="335000"/>
           </a:xfrm>
           <a:prstGeom prst="rect">
@@ -18601,7 +18601,7 @@
         </p:nvSpPr>
         <p:spPr>
           <a:xfrm>
-            <a:off x="6310473" y="2486000"/>
+            <a:off x="6310473" y="2386000"/>
             <a:ext cx="2756376" cy="335000"/>
           </a:xfrm>
           <a:prstGeom prst="rect">
@@ -18650,7 +18650,7 @@
         </p:nvSpPr>
         <p:spPr>
           <a:xfrm>
-            <a:off x="9066849" y="2486000"/>
+            <a:off x="9066849" y="2386000"/>
             <a:ext cx="2756376" cy="335000"/>
           </a:xfrm>
           <a:prstGeom prst="rect">
@@ -18681,7 +18681,7 @@
         </p:nvSpPr>
         <p:spPr>
           <a:xfrm>
-            <a:off x="9066849" y="2486000"/>
+            <a:off x="9066849" y="2386000"/>
             <a:ext cx="2756376" cy="335000"/>
           </a:xfrm>
           <a:prstGeom prst="rect">
@@ -18730,7 +18730,7 @@
         </p:nvSpPr>
         <p:spPr>
           <a:xfrm>
-            <a:off x="338325" y="2821000"/>
+            <a:off x="338325" y="2721000"/>
             <a:ext cx="5972148" cy="335000"/>
           </a:xfrm>
           <a:prstGeom prst="rect">
@@ -18761,7 +18761,7 @@
         </p:nvSpPr>
         <p:spPr>
           <a:xfrm>
-            <a:off x="338325" y="2821000"/>
+            <a:off x="338325" y="2721000"/>
             <a:ext cx="5972148" cy="335000"/>
           </a:xfrm>
           <a:prstGeom prst="rect">
@@ -18810,7 +18810,7 @@
         </p:nvSpPr>
         <p:spPr>
           <a:xfrm>
-            <a:off x="6310473" y="2821000"/>
+            <a:off x="6310473" y="2721000"/>
             <a:ext cx="2756376" cy="335000"/>
           </a:xfrm>
           <a:prstGeom prst="rect">
@@ -18841,7 +18841,7 @@
         </p:nvSpPr>
         <p:spPr>
           <a:xfrm>
-            <a:off x="6310473" y="2821000"/>
+            <a:off x="6310473" y="2721000"/>
             <a:ext cx="2756376" cy="335000"/>
           </a:xfrm>
           <a:prstGeom prst="rect">
@@ -18890,7 +18890,7 @@
         </p:nvSpPr>
         <p:spPr>
           <a:xfrm>
-            <a:off x="9066849" y="2821000"/>
+            <a:off x="9066849" y="2721000"/>
             <a:ext cx="2756376" cy="335000"/>
           </a:xfrm>
           <a:prstGeom prst="rect">
@@ -18921,7 +18921,7 @@
         </p:nvSpPr>
         <p:spPr>
           <a:xfrm>
-            <a:off x="9066849" y="2821000"/>
+            <a:off x="9066849" y="2721000"/>
             <a:ext cx="2756376" cy="335000"/>
           </a:xfrm>
           <a:prstGeom prst="rect">
@@ -18970,7 +18970,7 @@
         </p:nvSpPr>
         <p:spPr>
           <a:xfrm>
-            <a:off x="338325" y="3156000"/>
+            <a:off x="338325" y="3056000"/>
             <a:ext cx="11484900" cy="285000"/>
           </a:xfrm>
           <a:prstGeom prst="rect">
@@ -19001,7 +19001,7 @@
         </p:nvSpPr>
         <p:spPr>
           <a:xfrm>
-            <a:off x="338325" y="3156000"/>
+            <a:off x="338325" y="3056000"/>
             <a:ext cx="11484900" cy="285000"/>
           </a:xfrm>
           <a:prstGeom prst="rect">
@@ -19050,7 +19050,7 @@
         </p:nvSpPr>
         <p:spPr>
           <a:xfrm>
-            <a:off x="338325" y="3441000"/>
+            <a:off x="338325" y="3341000"/>
             <a:ext cx="5972148" cy="335000"/>
           </a:xfrm>
           <a:prstGeom prst="rect">
@@ -19081,7 +19081,7 @@
         </p:nvSpPr>
         <p:spPr>
           <a:xfrm>
-            <a:off x="338325" y="3441000"/>
+            <a:off x="338325" y="3341000"/>
             <a:ext cx="5972148" cy="335000"/>
           </a:xfrm>
           <a:prstGeom prst="rect">
@@ -19130,7 +19130,7 @@
         </p:nvSpPr>
         <p:spPr>
           <a:xfrm>
-            <a:off x="6310473" y="3441000"/>
+            <a:off x="6310473" y="3341000"/>
             <a:ext cx="2756376" cy="335000"/>
           </a:xfrm>
           <a:prstGeom prst="rect">
@@ -19161,7 +19161,7 @@
         </p:nvSpPr>
         <p:spPr>
           <a:xfrm>
-            <a:off x="6310473" y="3441000"/>
+            <a:off x="6310473" y="3341000"/>
             <a:ext cx="2756376" cy="335000"/>
           </a:xfrm>
           <a:prstGeom prst="rect">
@@ -19210,7 +19210,7 @@
         </p:nvSpPr>
         <p:spPr>
           <a:xfrm>
-            <a:off x="9066849" y="3441000"/>
+            <a:off x="9066849" y="3341000"/>
             <a:ext cx="2756376" cy="335000"/>
           </a:xfrm>
           <a:prstGeom prst="rect">
@@ -19241,7 +19241,7 @@
         </p:nvSpPr>
         <p:spPr>
           <a:xfrm>
-            <a:off x="9066849" y="3441000"/>
+            <a:off x="9066849" y="3341000"/>
             <a:ext cx="2756376" cy="335000"/>
           </a:xfrm>
           <a:prstGeom prst="rect">
@@ -19290,7 +19290,7 @@
         </p:nvSpPr>
         <p:spPr>
           <a:xfrm>
-            <a:off x="338325" y="3776000"/>
+            <a:off x="338325" y="3676000"/>
             <a:ext cx="11484900" cy="285000"/>
           </a:xfrm>
           <a:prstGeom prst="rect">
@@ -19321,7 +19321,7 @@
         </p:nvSpPr>
         <p:spPr>
           <a:xfrm>
-            <a:off x="338325" y="3776000"/>
+            <a:off x="338325" y="3676000"/>
             <a:ext cx="11484900" cy="285000"/>
           </a:xfrm>
           <a:prstGeom prst="rect">
@@ -19370,7 +19370,7 @@
         </p:nvSpPr>
         <p:spPr>
           <a:xfrm>
-            <a:off x="338325" y="4061000"/>
+            <a:off x="338325" y="3961000"/>
             <a:ext cx="5972148" cy="335000"/>
           </a:xfrm>
           <a:prstGeom prst="rect">
@@ -19401,7 +19401,7 @@
         </p:nvSpPr>
         <p:spPr>
           <a:xfrm>
-            <a:off x="338325" y="4061000"/>
+            <a:off x="338325" y="3961000"/>
             <a:ext cx="5972148" cy="335000"/>
           </a:xfrm>
           <a:prstGeom prst="rect">
@@ -19450,7 +19450,7 @@
         </p:nvSpPr>
         <p:spPr>
           <a:xfrm>
-            <a:off x="6310473" y="4061000"/>
+            <a:off x="6310473" y="3961000"/>
             <a:ext cx="2756376" cy="335000"/>
           </a:xfrm>
           <a:prstGeom prst="rect">
@@ -19481,7 +19481,7 @@
         </p:nvSpPr>
         <p:spPr>
           <a:xfrm>
-            <a:off x="6310473" y="4061000"/>
+            <a:off x="6310473" y="3961000"/>
             <a:ext cx="2756376" cy="335000"/>
           </a:xfrm>
           <a:prstGeom prst="rect">
@@ -19530,7 +19530,7 @@
         </p:nvSpPr>
         <p:spPr>
           <a:xfrm>
-            <a:off x="9066849" y="4061000"/>
+            <a:off x="9066849" y="3961000"/>
             <a:ext cx="2756376" cy="335000"/>
           </a:xfrm>
           <a:prstGeom prst="rect">
@@ -19561,7 +19561,7 @@
         </p:nvSpPr>
         <p:spPr>
           <a:xfrm>
-            <a:off x="9066849" y="4061000"/>
+            <a:off x="9066849" y="3961000"/>
             <a:ext cx="2756376" cy="335000"/>
           </a:xfrm>
           <a:prstGeom prst="rect">
@@ -19610,7 +19610,7 @@
         </p:nvSpPr>
         <p:spPr>
           <a:xfrm>
-            <a:off x="338325" y="4396000"/>
+            <a:off x="338325" y="4296000"/>
             <a:ext cx="5972148" cy="335000"/>
           </a:xfrm>
           <a:prstGeom prst="rect">
@@ -19641,7 +19641,7 @@
         </p:nvSpPr>
         <p:spPr>
           <a:xfrm>
-            <a:off x="338325" y="4396000"/>
+            <a:off x="338325" y="4296000"/>
             <a:ext cx="5972148" cy="335000"/>
           </a:xfrm>
           <a:prstGeom prst="rect">
@@ -19690,7 +19690,7 @@
         </p:nvSpPr>
         <p:spPr>
           <a:xfrm>
-            <a:off x="6310473" y="4396000"/>
+            <a:off x="6310473" y="4296000"/>
             <a:ext cx="2756376" cy="335000"/>
           </a:xfrm>
           <a:prstGeom prst="rect">
@@ -19721,7 +19721,7 @@
         </p:nvSpPr>
         <p:spPr>
           <a:xfrm>
-            <a:off x="6310473" y="4396000"/>
+            <a:off x="6310473" y="4296000"/>
             <a:ext cx="2756376" cy="335000"/>
           </a:xfrm>
           <a:prstGeom prst="rect">
@@ -19770,7 +19770,7 @@
         </p:nvSpPr>
         <p:spPr>
           <a:xfrm>
-            <a:off x="9066849" y="4396000"/>
+            <a:off x="9066849" y="4296000"/>
             <a:ext cx="2756376" cy="335000"/>
           </a:xfrm>
           <a:prstGeom prst="rect">
@@ -19801,7 +19801,7 @@
         </p:nvSpPr>
         <p:spPr>
           <a:xfrm>
-            <a:off x="9066849" y="4396000"/>
+            <a:off x="9066849" y="4296000"/>
             <a:ext cx="2756376" cy="335000"/>
           </a:xfrm>
           <a:prstGeom prst="rect">
@@ -19850,8 +19850,8 @@
         </p:nvSpPr>
         <p:spPr>
           <a:xfrm>
-            <a:off x="338325" y="4831000"/>
-            <a:ext cx="11484900" cy="1450000"/>
+            <a:off x="338325" y="4731000"/>
+            <a:ext cx="11484900" cy="1650000"/>
           </a:xfrm>
           <a:prstGeom prst="roundRect">
             <a:avLst>
@@ -19932,7 +19932,7 @@
                 <a:spcPts val="150"/>
               </a:spcBef>
               <a:spcAft>
-                <a:spcPts val="100"/>
+                <a:spcPts val="0"/>
               </a:spcAft>
               <a:buClr>
                 <a:srgbClr val="891019"/>
@@ -19943,6 +19943,29 @@
             <a:r>
               <a:rPr lang="en-US" sz="1650"/>
               <a:t>Cursors expire like API query cursors — see API Query Cursor Limits in Salesforce Help.</a:t>
+            </a:r>
+            <a:endParaRPr/>
+          </a:p>
+          <a:p>
+            <a:pPr indent="-285750" lvl="0" marL="457200" rtl="0" algn="l">
+              <a:lnSpc>
+                <a:spcPct val="112000"/>
+              </a:lnSpc>
+              <a:spcBef>
+                <a:spcPts val="150"/>
+              </a:spcBef>
+              <a:spcAft>
+                <a:spcPts val="100"/>
+              </a:spcAft>
+              <a:buClr>
+                <a:srgbClr val="891019"/>
+              </a:buClr>
+              <a:buSzPts val="1500"/>
+              <a:buChar char="•"/>
+            </a:pPr>
+            <a:r>
+              <a:rPr lang="en-US" sz="1650"/>
+              <a:t>Aggregate, subselect and virtual object queries are not supported.</a:t>
             </a:r>
             <a:endParaRPr/>
           </a:p>
@@ -23729,7 +23752,7 @@
             </a:pPr>
             <a:r>
               <a:rPr lang="en-US" sz="1800"/>
-              <a:t>Optional Cache.Session keeps the pagination cursor across user session</a:t>
+              <a:t>Cache.Session keeps the pagination cursor between requests; session cache and cursors are per user</a:t>
             </a:r>
             <a:endParaRPr/>
           </a:p>

</xml_diff>